<commit_message>
Clarify serialization rules text in channel-one card (pptx and html v8)
Co-authored-by: helloKitty01 <helloKitty01@users.noreply.github.com>
</commit_message>
<xml_diff>
--- a/kv-cache-discussion/上下文工程与KV-Cache优化.pptx
+++ b/kv-cache-discussion/上下文工程与KV-Cache优化.pptx
@@ -7275,7 +7275,7 @@
         <p:spPr>
           <a:xfrm>
             <a:off x="6995160" y="896112"/>
-            <a:ext cx="4873752" cy="2377440"/>
+            <a:ext cx="4873752" cy="2395728"/>
           </a:xfrm>
           <a:prstGeom prst="roundRect">
             <a:avLst>
@@ -7383,7 +7383,7 @@
         <p:spPr>
           <a:xfrm>
             <a:off x="7159752" y="1280160"/>
-            <a:ext cx="4544568" cy="1170432"/>
+            <a:ext cx="4544568" cy="1115568"/>
           </a:xfrm>
           <a:prstGeom prst="rect">
             <a:avLst/>
@@ -7428,8 +7428,213 @@
         </p:nvSpPr>
         <p:spPr>
           <a:xfrm>
-            <a:off x="7269480" y="1344168"/>
-            <a:ext cx="4325112" cy="1060704"/>
+            <a:off x="7269480" y="1335024"/>
+            <a:ext cx="4325112" cy="1024128"/>
+          </a:xfrm>
+          <a:prstGeom prst="rect">
+            <a:avLst/>
+          </a:prstGeom>
+          <a:noFill/>
+        </p:spPr>
+        <p:txBody>
+          <a:bodyPr wrap="square" anchor="t" lIns="0" rIns="0" tIns="0" bIns="0">
+            <a:spAutoFit/>
+          </a:bodyPr>
+          <a:lstStyle/>
+          <a:p>
+            <a:pPr algn="l">
+              <a:lnSpc>
+                <a:spcPct val="110000"/>
+              </a:lnSpc>
+            </a:pPr>
+            <a:r>
+              <a:rPr sz="800" b="0">
+                <a:solidFill>
+                  <a:srgbClr val="64748B"/>
+                </a:solidFill>
+                <a:latin typeface="Consolas"/>
+                <a:ea typeface="Microsoft YaHei"/>
+              </a:rPr>
+              <a:t>&lt;turn_context&gt;</a:t>
+            </a:r>
+          </a:p>
+          <a:p>
+            <a:pPr algn="l">
+              <a:lnSpc>
+                <a:spcPct val="110000"/>
+              </a:lnSpc>
+            </a:pPr>
+            <a:r>
+              <a:rPr sz="800" b="0">
+                <a:solidFill>
+                  <a:srgbClr val="2563EB"/>
+                </a:solidFill>
+                <a:latin typeface="Consolas"/>
+                <a:ea typeface="Microsoft YaHei"/>
+              </a:rPr>
+              <a:t>  &lt;env&gt;</a:t>
+            </a:r>
+            <a:r>
+              <a:rPr sz="800" b="0">
+                <a:solidFill>
+                  <a:srgbClr val="1F2937"/>
+                </a:solidFill>
+                <a:latin typeface="Consolas"/>
+                <a:ea typeface="Microsoft YaHei"/>
+              </a:rPr>
+              <a:t>环境增量（首轮全量快照，此后只注增量）</a:t>
+            </a:r>
+            <a:r>
+              <a:rPr sz="800" b="0">
+                <a:solidFill>
+                  <a:srgbClr val="2563EB"/>
+                </a:solidFill>
+                <a:latin typeface="Consolas"/>
+                <a:ea typeface="Microsoft YaHei"/>
+              </a:rPr>
+              <a:t>&lt;/env&gt;</a:t>
+            </a:r>
+          </a:p>
+          <a:p>
+            <a:pPr algn="l">
+              <a:lnSpc>
+                <a:spcPct val="110000"/>
+              </a:lnSpc>
+            </a:pPr>
+            <a:r>
+              <a:rPr sz="800" b="0">
+                <a:solidFill>
+                  <a:srgbClr val="059669"/>
+                </a:solidFill>
+                <a:latin typeface="Consolas"/>
+                <a:ea typeface="Microsoft YaHei"/>
+              </a:rPr>
+              <a:t>  &lt;retrieved&gt;</a:t>
+            </a:r>
+            <a:r>
+              <a:rPr sz="800" b="0">
+                <a:solidFill>
+                  <a:srgbClr val="1F2937"/>
+                </a:solidFill>
+                <a:latin typeface="Consolas"/>
+                <a:ea typeface="Microsoft YaHei"/>
+              </a:rPr>
+              <a:t>相关知识/用户信息（ID 去重，只注新条目）</a:t>
+            </a:r>
+            <a:r>
+              <a:rPr sz="800" b="0">
+                <a:solidFill>
+                  <a:srgbClr val="059669"/>
+                </a:solidFill>
+                <a:latin typeface="Consolas"/>
+                <a:ea typeface="Microsoft YaHei"/>
+              </a:rPr>
+              <a:t>&lt;/retrieved&gt;</a:t>
+            </a:r>
+          </a:p>
+          <a:p>
+            <a:pPr algn="l">
+              <a:lnSpc>
+                <a:spcPct val="110000"/>
+              </a:lnSpc>
+            </a:pPr>
+            <a:r>
+              <a:rPr sz="800" b="0">
+                <a:solidFill>
+                  <a:srgbClr val="D97706"/>
+                </a:solidFill>
+                <a:latin typeface="Consolas"/>
+                <a:ea typeface="Microsoft YaHei"/>
+              </a:rPr>
+              <a:t>  &lt;skills&gt;</a:t>
+            </a:r>
+            <a:r>
+              <a:rPr sz="800" b="0">
+                <a:solidFill>
+                  <a:srgbClr val="1F2937"/>
+                </a:solidFill>
+                <a:latin typeface="Consolas"/>
+                <a:ea typeface="Microsoft YaHei"/>
+              </a:rPr>
+              <a:t>available skills（方案 A 的注入位置）</a:t>
+            </a:r>
+            <a:r>
+              <a:rPr sz="800" b="0">
+                <a:solidFill>
+                  <a:srgbClr val="D97706"/>
+                </a:solidFill>
+                <a:latin typeface="Consolas"/>
+                <a:ea typeface="Microsoft YaHei"/>
+              </a:rPr>
+              <a:t>&lt;/skills&gt;</a:t>
+            </a:r>
+          </a:p>
+          <a:p>
+            <a:pPr algn="l">
+              <a:lnSpc>
+                <a:spcPct val="110000"/>
+              </a:lnSpc>
+            </a:pPr>
+            <a:r>
+              <a:rPr sz="800" b="0">
+                <a:solidFill>
+                  <a:srgbClr val="64748B"/>
+                </a:solidFill>
+                <a:latin typeface="Consolas"/>
+                <a:ea typeface="Microsoft YaHei"/>
+              </a:rPr>
+              <a:t>&lt;/turn_context&gt;</a:t>
+            </a:r>
+          </a:p>
+          <a:p>
+            <a:pPr algn="l">
+              <a:lnSpc>
+                <a:spcPct val="110000"/>
+              </a:lnSpc>
+            </a:pPr>
+            <a:r>
+              <a:rPr sz="800" b="0">
+                <a:solidFill>
+                  <a:srgbClr val="2563EB"/>
+                </a:solidFill>
+                <a:latin typeface="Consolas"/>
+                <a:ea typeface="Microsoft YaHei"/>
+              </a:rPr>
+              <a:t>&lt;query&gt;</a:t>
+            </a:r>
+            <a:r>
+              <a:rPr sz="800" b="0">
+                <a:solidFill>
+                  <a:srgbClr val="1F2937"/>
+                </a:solidFill>
+                <a:latin typeface="Consolas"/>
+                <a:ea typeface="Microsoft YaHei"/>
+              </a:rPr>
+              <a:t>用户原文，永远置于消息最后</a:t>
+            </a:r>
+            <a:r>
+              <a:rPr sz="800" b="0">
+                <a:solidFill>
+                  <a:srgbClr val="2563EB"/>
+                </a:solidFill>
+                <a:latin typeface="Consolas"/>
+                <a:ea typeface="Microsoft YaHei"/>
+              </a:rPr>
+              <a:t>&lt;/query&gt;</a:t>
+            </a:r>
+          </a:p>
+        </p:txBody>
+      </p:sp>
+      <p:sp>
+        <p:nvSpPr>
+          <p:cNvPr id="36" name="TextBox 35"/>
+          <p:cNvSpPr txBox="1"/>
+          <p:nvPr/>
+        </p:nvSpPr>
+        <p:spPr>
+          <a:xfrm>
+            <a:off x="7159752" y="2450592"/>
+            <a:ext cx="4544568" cy="786384"/>
           </a:xfrm>
           <a:prstGeom prst="rect">
             <a:avLst/>
@@ -7448,14 +7653,14 @@
               </a:lnSpc>
             </a:pPr>
             <a:r>
-              <a:rPr sz="800" b="0">
+              <a:rPr sz="840" b="0">
                 <a:solidFill>
                   <a:srgbClr val="64748B"/>
                 </a:solidFill>
-                <a:latin typeface="Consolas"/>
-                <a:ea typeface="Microsoft YaHei"/>
-              </a:rPr>
-              <a:t>&lt;turn_context&gt;</a:t>
+                <a:latin typeface="Microsoft YaHei"/>
+                <a:ea typeface="Microsoft YaHei"/>
+              </a:rPr>
+              <a:t>· 拼接结果逐字节稳定：标签顺序/条目排序固定、空块不输出、发出后不再修改（否则缓存悄悄失效）</a:t>
             </a:r>
           </a:p>
           <a:p>
@@ -7465,222 +7670,34 @@
               </a:lnSpc>
             </a:pPr>
             <a:r>
-              <a:rPr sz="800" b="0">
-                <a:solidFill>
-                  <a:srgbClr val="2563EB"/>
-                </a:solidFill>
-                <a:latin typeface="Consolas"/>
-                <a:ea typeface="Microsoft YaHei"/>
-              </a:rPr>
-              <a:t>  &lt;env&gt;</a:t>
-            </a:r>
-            <a:r>
-              <a:rPr sz="800" b="0">
+              <a:rPr sz="840" b="0">
+                <a:solidFill>
+                  <a:srgbClr val="64748B"/>
+                </a:solidFill>
+                <a:latin typeface="Microsoft YaHei"/>
+                <a:ea typeface="Microsoft YaHei"/>
+              </a:rPr>
+              <a:t>· 检索内容与 query </a:t>
+            </a:r>
+            <a:r>
+              <a:rPr sz="840" b="1">
                 <a:solidFill>
                   <a:srgbClr val="1F2937"/>
                 </a:solidFill>
-                <a:latin typeface="Consolas"/>
-                <a:ea typeface="Microsoft YaHei"/>
-              </a:rPr>
-              <a:t>环境增量（首轮全量快照，此后只注增量）</a:t>
-            </a:r>
-            <a:r>
-              <a:rPr sz="800" b="0">
-                <a:solidFill>
-                  <a:srgbClr val="2563EB"/>
-                </a:solidFill>
-                <a:latin typeface="Consolas"/>
-                <a:ea typeface="Microsoft YaHei"/>
-              </a:rPr>
-              <a:t>&lt;/env&gt;</a:t>
-            </a:r>
-          </a:p>
-          <a:p>
-            <a:pPr algn="l">
-              <a:lnSpc>
-                <a:spcPct val="112000"/>
-              </a:lnSpc>
-            </a:pPr>
-            <a:r>
-              <a:rPr sz="800" b="0">
-                <a:solidFill>
-                  <a:srgbClr val="059669"/>
-                </a:solidFill>
-                <a:latin typeface="Consolas"/>
-                <a:ea typeface="Microsoft YaHei"/>
-              </a:rPr>
-              <a:t>  &lt;retrieved&gt;</a:t>
-            </a:r>
-            <a:r>
-              <a:rPr sz="800" b="0">
-                <a:solidFill>
-                  <a:srgbClr val="1F2937"/>
-                </a:solidFill>
-                <a:latin typeface="Consolas"/>
-                <a:ea typeface="Microsoft YaHei"/>
-              </a:rPr>
-              <a:t>相关知识/用户信息（ID 去重，只注新条目）</a:t>
-            </a:r>
-            <a:r>
-              <a:rPr sz="800" b="0">
-                <a:solidFill>
-                  <a:srgbClr val="059669"/>
-                </a:solidFill>
-                <a:latin typeface="Consolas"/>
-                <a:ea typeface="Microsoft YaHei"/>
-              </a:rPr>
-              <a:t>&lt;/retrieved&gt;</a:t>
-            </a:r>
-          </a:p>
-          <a:p>
-            <a:pPr algn="l">
-              <a:lnSpc>
-                <a:spcPct val="112000"/>
-              </a:lnSpc>
-            </a:pPr>
-            <a:r>
-              <a:rPr sz="800" b="0">
-                <a:solidFill>
-                  <a:srgbClr val="D97706"/>
-                </a:solidFill>
-                <a:latin typeface="Consolas"/>
-                <a:ea typeface="Microsoft YaHei"/>
-              </a:rPr>
-              <a:t>  &lt;skills&gt;</a:t>
-            </a:r>
-            <a:r>
-              <a:rPr sz="800" b="0">
-                <a:solidFill>
-                  <a:srgbClr val="1F2937"/>
-                </a:solidFill>
-                <a:latin typeface="Consolas"/>
-                <a:ea typeface="Microsoft YaHei"/>
-              </a:rPr>
-              <a:t>available skills（方案 A 的注入位置）</a:t>
-            </a:r>
-            <a:r>
-              <a:rPr sz="800" b="0">
-                <a:solidFill>
-                  <a:srgbClr val="D97706"/>
-                </a:solidFill>
-                <a:latin typeface="Consolas"/>
-                <a:ea typeface="Microsoft YaHei"/>
-              </a:rPr>
-              <a:t>&lt;/skills&gt;</a:t>
-            </a:r>
-          </a:p>
-          <a:p>
-            <a:pPr algn="l">
-              <a:lnSpc>
-                <a:spcPct val="112000"/>
-              </a:lnSpc>
-            </a:pPr>
-            <a:r>
-              <a:rPr sz="800" b="0">
+                <a:latin typeface="Microsoft YaHei"/>
+                <a:ea typeface="Microsoft YaHei"/>
+              </a:rPr>
+              <a:t>同消息相邻、永久留在历史</a:t>
+            </a:r>
+            <a:r>
+              <a:rPr sz="840" b="0">
                 <a:solidFill>
                   <a:srgbClr val="64748B"/>
                 </a:solidFill>
-                <a:latin typeface="Consolas"/>
-                <a:ea typeface="Microsoft YaHei"/>
-              </a:rPr>
-              <a:t>&lt;/turn_context&gt;</a:t>
-            </a:r>
-          </a:p>
-          <a:p>
-            <a:pPr algn="l">
-              <a:lnSpc>
-                <a:spcPct val="112000"/>
-              </a:lnSpc>
-            </a:pPr>
-            <a:r>
-              <a:rPr sz="800" b="0">
-                <a:solidFill>
-                  <a:srgbClr val="2563EB"/>
-                </a:solidFill>
-                <a:latin typeface="Consolas"/>
-                <a:ea typeface="Microsoft YaHei"/>
-              </a:rPr>
-              <a:t>&lt;query&gt;</a:t>
-            </a:r>
-            <a:r>
-              <a:rPr sz="800" b="0">
-                <a:solidFill>
-                  <a:srgbClr val="1F2937"/>
-                </a:solidFill>
-                <a:latin typeface="Consolas"/>
-                <a:ea typeface="Microsoft YaHei"/>
-              </a:rPr>
-              <a:t>用户原文，永远置于消息最后</a:t>
-            </a:r>
-            <a:r>
-              <a:rPr sz="800" b="0">
-                <a:solidFill>
-                  <a:srgbClr val="2563EB"/>
-                </a:solidFill>
-                <a:latin typeface="Consolas"/>
-                <a:ea typeface="Microsoft YaHei"/>
-              </a:rPr>
-              <a:t>&lt;/query&gt;</a:t>
-            </a:r>
-          </a:p>
-        </p:txBody>
-      </p:sp>
-      <p:sp>
-        <p:nvSpPr>
-          <p:cNvPr id="36" name="TextBox 35"/>
-          <p:cNvSpPr txBox="1"/>
-          <p:nvPr/>
-        </p:nvSpPr>
-        <p:spPr>
-          <a:xfrm>
-            <a:off x="7159752" y="2523744"/>
-            <a:ext cx="4544568" cy="676656"/>
-          </a:xfrm>
-          <a:prstGeom prst="rect">
-            <a:avLst/>
-          </a:prstGeom>
-          <a:noFill/>
-        </p:spPr>
-        <p:txBody>
-          <a:bodyPr wrap="square" anchor="t" lIns="0" rIns="0" tIns="0" bIns="0">
-            <a:spAutoFit/>
-          </a:bodyPr>
-          <a:lstStyle/>
-          <a:p>
-            <a:pPr algn="l">
-              <a:lnSpc>
-                <a:spcPct val="105000"/>
-              </a:lnSpc>
-            </a:pPr>
-            <a:r>
-              <a:rPr sz="880" b="0">
-                <a:solidFill>
-                  <a:srgbClr val="64748B"/>
-                </a:solidFill>
-                <a:latin typeface="Microsoft YaHei"/>
-                <a:ea typeface="Microsoft YaHei"/>
-              </a:rPr>
-              <a:t>序列化完全确定性（标签与排序固定、空块省略、发出后永不回改）；检索内容与 query </a:t>
-            </a:r>
-            <a:r>
-              <a:rPr sz="880" b="1">
-                <a:solidFill>
-                  <a:srgbClr val="1F2937"/>
-                </a:solidFill>
-                <a:latin typeface="Microsoft YaHei"/>
-                <a:ea typeface="Microsoft YaHei"/>
-              </a:rPr>
-              <a:t>物理相邻、留在时间线</a:t>
-            </a:r>
-            <a:r>
-              <a:rPr sz="880" b="0">
-                <a:solidFill>
-                  <a:srgbClr val="64748B"/>
-                </a:solidFill>
-                <a:latin typeface="Microsoft YaHei"/>
-                <a:ea typeface="Microsoft YaHei"/>
-              </a:rPr>
-              <a:t>——同时治问题③</a:t>
+                <a:latin typeface="Microsoft YaHei"/>
+                <a:ea typeface="Microsoft YaHei"/>
+              </a:rPr>
+              <a:t>：对应关系模型可见，可去重、可审计（治问题③）</a:t>
             </a:r>
           </a:p>
         </p:txBody>

</xml_diff>